<commit_message>
docs(slides): met à jour les séances 2 et 3 et ajoute l'étude de cas PHP2Shell
- S02 : formulations revues, phrases plus fluides
- S03 : formulations revues, trois slides sur la culture (exemples,
  configuration, schéma navigateur fr-BE / serveur en-US)
- Étude de cas PHP2Shell (CVE-2026-109618 et CVE-2026-109619)

Co-Authored-By: Claude Opus 5.5 (1M context) <noreply@anthropic.com>
Claude-Session: https://claude.ai/code/session_01E4cv7wXdsCQKADZzQLwEbY
</commit_message>
<xml_diff>
--- a/slides/20260930_LLE_CA_S02.pptx
+++ b/slides/20260930_LLE_CA_S02.pptx
@@ -7207,7 +7207,7 @@
                 <a:ea typeface="Calibri" pitchFamily="34" charset="-122"/>
                 <a:cs typeface="Calibri" pitchFamily="34" charset="-120"/>
               </a:rPr>
-              <a:t>Le conseil depuis 1994</a:t>
+              <a:t>Un conseil qui date de 1994</a:t>
             </a:r>
             <a:endParaRPr lang="en-US" sz="1900" dirty="0"/>
           </a:p>
@@ -7876,8 +7876,14 @@
                 <a:ea typeface="Calibri" pitchFamily="34" charset="-122"/>
                 <a:cs typeface="Calibri" pitchFamily="34" charset="-120"/>
               </a:rPr>
-              <a:t>On ne conduit jamais « un véhicule » en général.</a:t>
-            </a:r>
+              <a:t>Personne ne conduit « un véhicule » en général : on conduit une voiture, une moto ou un camion.</a:t>
+            </a:r>
+            <a:endParaRPr lang="en-US" sz="1700" dirty="0"/>
+          </a:p>
+          <a:p>
+            <a:pPr indent="0" marL="0">
+              <a:buNone/>
+            </a:pPr>
             <a:endParaRPr lang="en-US" sz="1700" dirty="0"/>
           </a:p>
           <a:p>
@@ -7893,30 +7899,7 @@
                 <a:ea typeface="Calibri" pitchFamily="34" charset="-122"/>
                 <a:cs typeface="Calibri" pitchFamily="34" charset="-120"/>
               </a:rPr>
-              <a:t>On conduit une voiture, une moto, un camion.</a:t>
-            </a:r>
-            <a:endParaRPr lang="en-US" sz="1700" dirty="0"/>
-          </a:p>
-          <a:p>
-            <a:pPr indent="0" marL="0">
-              <a:buNone/>
-            </a:pPr>
-            <a:endParaRPr lang="en-US" sz="1700" dirty="0"/>
-          </a:p>
-          <a:p>
-            <a:pPr indent="0" marL="0">
-              <a:buNone/>
-            </a:pPr>
-            <a:r>
-              <a:rPr lang="en-US" sz="1700" dirty="0">
-                <a:solidFill>
-                  <a:srgbClr val="5F6670"/>
-                </a:solidFill>
-                <a:latin typeface="Calibri" pitchFamily="34" charset="0"/>
-                <a:ea typeface="Calibri" pitchFamily="34" charset="-122"/>
-                <a:cs typeface="Calibri" pitchFamily="34" charset="-120"/>
-              </a:rPr>
-              <a:t>« Véhicule » est une idée commune : abstraite.</a:t>
+              <a:t>« Véhicule » est une idée commune à tous, c'est-à-dire une abstraction.</a:t>
             </a:r>
             <a:endParaRPr lang="en-US" sz="1700" dirty="0"/>
           </a:p>
@@ -8919,7 +8902,7 @@
                 <a:ea typeface="Calibri" pitchFamily="34" charset="-122"/>
                 <a:cs typeface="Calibri" pitchFamily="34" charset="-120"/>
               </a:rPr>
-              <a:t>Aujourd'hui l'e-mail. Demain Teams. Après-demain un SMS pour les incidents critiques.</a:t>
+              <a:t>Aujourd'hui, on prévient par e-mail ; demain, peut-être par Teams ; plus tard, par SMS pour les incidents critiques.</a:t>
             </a:r>
             <a:endParaRPr lang="en-US" sz="1900" dirty="0"/>
           </a:p>
@@ -9405,7 +9388,7 @@
                 <a:ea typeface="Calibri" pitchFamily="34" charset="-122"/>
                 <a:cs typeface="Calibri" pitchFamily="34" charset="-120"/>
               </a:rPr>
-              <a:t>On veut qu'IncidentHub dise juste « prévenez », sans savoir comment.</a:t>
+              <a:t>On veut qu'IncidentHub puisse simplement dire « prévenez », sans avoir à savoir par quel canal le message part.</a:t>
             </a:r>
             <a:endParaRPr lang="en-US" sz="1900" dirty="0"/>
           </a:p>
@@ -9839,7 +9822,7 @@
                 <a:ea typeface="Calibri" pitchFamily="34" charset="-122"/>
                 <a:cs typeface="Calibri" pitchFamily="34" charset="-120"/>
               </a:rPr>
-              <a:t>Elle définit une norme. Lampe, chargeur ou grille-pain : tout ce qui respecte la norme s'y branche.</a:t>
+              <a:t>Elle définit une norme : une lampe, un chargeur ou un grille-pain peuvent s'y brancher dès qu'ils la respectent.</a:t>
             </a:r>
             <a:endParaRPr lang="en-US" sz="1900" dirty="0"/>
           </a:p>
@@ -9862,7 +9845,7 @@
                 <a:ea typeface="Calibri" pitchFamily="34" charset="-122"/>
                 <a:cs typeface="Calibri" pitchFamily="34" charset="-120"/>
               </a:rPr>
-              <a:t>La prise ne sait pas ce qu'on y branche. Elle n'en a pas besoin.</a:t>
+              <a:t>La prise ne sait pas ce qu'on y branche, et elle n'a pas besoin de le savoir.</a:t>
             </a:r>
             <a:endParaRPr lang="en-US" sz="1900" dirty="0"/>
           </a:p>
@@ -13017,7 +13000,7 @@
                 <a:cs typeface="Calibri" pitchFamily="34" charset="-120"/>
               </a:rPr>
               <a:t>
-Le même bouton. L'imprimante, le PDF ou l'e-mail : chacun fait son travail à sa façon.
+On clique toujours sur le même bouton ; selon le choix, c'est l'imprimante, le PDF ou l'e-mail qui fait le travail, chacun à sa façon.
 </a:t>
             </a:r>
             <a:endParaRPr lang="en-US" sz="1900" dirty="0"/>
@@ -13035,7 +13018,7 @@
                 <a:ea typeface="Calibri" pitchFamily="34" charset="-122"/>
                 <a:cs typeface="Calibri" pitchFamily="34" charset="-120"/>
               </a:rPr>
-              <a:t>« Polymorphisme » : du grec, « plusieurs formes ».</a:t>
+              <a:t>Le mot « polymorphisme » vient du grec et signifie « plusieurs formes ».</a:t>
             </a:r>
             <a:endParaRPr lang="en-US" sz="1900" dirty="0"/>
           </a:p>
@@ -16673,7 +16656,7 @@
                 <a:ea typeface="Calibri" pitchFamily="34" charset="-122"/>
                 <a:cs typeface="Calibri" pitchFamily="34" charset="-120"/>
               </a:rPr>
-              <a:t>Souvent le premier dessin avec un client : il fixe le périmètre avant tout code.</a:t>
+              <a:t>C'est souvent le premier schéma dessiné avec un client : il fixe le périmètre avant la première ligne de code.</a:t>
             </a:r>
             <a:endParaRPr lang="en-US" sz="1600" dirty="0"/>
           </a:p>
@@ -17485,7 +17468,7 @@
                 <a:ea typeface="Calibri" pitchFamily="34" charset="-122"/>
                 <a:cs typeface="Calibri" pitchFamily="34" charset="-120"/>
               </a:rPr>
-              <a:t>Même idée. Activités pour l'équipe de développement, BPMN pour le métier et les moteurs de workflow.</a:t>
+              <a:t>L'idée est la même : le diagramme d'activités s'adresse plutôt à l'équipe de développement, BPMN au métier et aux moteurs de workflow.</a:t>
             </a:r>
             <a:endParaRPr lang="en-US" sz="1350" dirty="0"/>
           </a:p>
@@ -20311,7 +20294,7 @@
                 <a:ea typeface="Calibri" pitchFamily="34" charset="-122"/>
                 <a:cs typeface="Calibri" pitchFamily="34" charset="-120"/>
               </a:rPr>
-              <a:t>L'IA relie tout par héritage. C'est à vous de poser la question « est-ce vraiment un… ? »</a:t>
+              <a:t>L'IA a tendance à tout relier par héritage : c'est à vous de vérifier, à chaque fois, que la relation « est un » est juste.</a:t>
             </a:r>
             <a:endParaRPr lang="en-US" sz="1600" dirty="0"/>
           </a:p>
@@ -20764,7 +20747,7 @@
                 <a:ea typeface="Arial" pitchFamily="34" charset="-122"/>
                 <a:cs typeface="Arial" pitchFamily="34" charset="-120"/>
               </a:rPr>
-              <a:t>Pas de modèle parfait : des compromis. Dans notre modèle, on garde l'héritage.</a:t>
+              <a:t>Il n'existe pas de modèle parfait, seulement des compromis ; pour IncidentHub, on garde l'héritage.</a:t>
             </a:r>
             <a:endParaRPr lang="en-US" sz="1800" dirty="0"/>
           </a:p>
@@ -22737,8 +22720,8 @@
         </p:nvSpPr>
         <p:spPr>
           <a:xfrm>
-            <a:off x="640080" y="1691640"/>
-            <a:ext cx="10911535" cy="457200"/>
+            <a:off x="640080" y="1645920"/>
+            <a:ext cx="10911535" cy="548640"/>
           </a:xfrm>
           <a:prstGeom prst="rect">
             <a:avLst/>
@@ -22754,7 +22737,7 @@
               <a:buNone/>
             </a:pPr>
             <a:r>
-              <a:rPr lang="en-US" sz="1800" dirty="0">
+              <a:rPr lang="en-US" sz="1550" dirty="0">
                 <a:solidFill>
                   <a:srgbClr val="5F6670"/>
                 </a:solidFill>
@@ -22762,9 +22745,9 @@
                 <a:ea typeface="Calibri" pitchFamily="34" charset="-122"/>
                 <a:cs typeface="Calibri" pitchFamily="34" charset="-120"/>
               </a:rPr>
-              <a:t>Une propriété = une case du formulaire, avec deux portes : get (lire) et set (écrire).</a:t>
-            </a:r>
-            <a:endParaRPr lang="en-US" sz="1800" dirty="0"/>
+              <a:t>Une propriété fonctionne comme une case de formulaire qui aurait deux portes : get permet de lire la valeur, set permet de l'écrire.</a:t>
+            </a:r>
+            <a:endParaRPr lang="en-US" sz="1550" dirty="0"/>
           </a:p>
         </p:txBody>
       </p:sp>
@@ -25422,7 +25405,7 @@
                 <a:ea typeface="Calibri" pitchFamily="34" charset="-122"/>
                 <a:cs typeface="Calibri" pitchFamily="34" charset="-120"/>
               </a:rPr>
-              <a:t>Le compilateur fait respecter l'encapsulation, avant même l'exécution.</a:t>
+              <a:t>C'est le compilateur qui fait respecter l'encapsulation, avant même l'exécution.</a:t>
             </a:r>
             <a:endParaRPr lang="en-US" sz="1400" dirty="0"/>
           </a:p>
@@ -26244,7 +26227,7 @@
                 <a:ea typeface="Calibri" pitchFamily="34" charset="-122"/>
                 <a:cs typeface="Calibri" pitchFamily="34" charset="-120"/>
               </a:rPr>
-              <a:t>« Getter » et « setter » : les méthodes get et set de Java. C# les écrit en une ligne.</a:t>
+              <a:t>Les mots « getter » et « setter » viennent de ces méthodes get et set de Java ; C# permet d'écrire la même chose en une seule ligne.</a:t>
             </a:r>
             <a:endParaRPr lang="en-US" sz="1700" dirty="0"/>
           </a:p>
@@ -27209,7 +27192,7 @@
                 <a:ea typeface="Calibri" pitchFamily="34" charset="-122"/>
                 <a:cs typeface="Calibri" pitchFamily="34" charset="-120"/>
               </a:rPr>
-              <a:t>Les mêmes attributs, copiés trois fois.</a:t>
+              <a:t>Le nom et l'e-mail sont recopiés dans chacune des trois classes.</a:t>
             </a:r>
             <a:endParaRPr lang="en-US" sz="1800" dirty="0"/>
           </a:p>
@@ -27275,7 +27258,7 @@
                 <a:ea typeface="Calibri" pitchFamily="34" charset="-122"/>
                 <a:cs typeface="Calibri" pitchFamily="34" charset="-120"/>
               </a:rPr>
-              <a:t>Le jour où…</a:t>
+              <a:t>Le risque</a:t>
             </a:r>
             <a:endParaRPr lang="en-US" sz="1800" dirty="0"/>
           </a:p>
@@ -27290,7 +27273,7 @@
               <a:buNone/>
             </a:pPr>
             <a:r>
-              <a:rPr lang="en-US" sz="1600" dirty="0">
+              <a:rPr lang="en-US" sz="1500" dirty="0">
                 <a:solidFill>
                   <a:srgbClr val="FFFFFF"/>
                 </a:solidFill>
@@ -27298,7 +27281,7 @@
                 <a:ea typeface="Calibri" pitchFamily="34" charset="-122"/>
                 <a:cs typeface="Calibri" pitchFamily="34" charset="-120"/>
               </a:rPr>
-              <a:t>… on ajoute un téléphone, il faut le faire trois fois. Et on en oublie une.</a:t>
+              <a:t>Le jour où l'on ajoute un numéro de téléphone, il faut le faire trois fois, et on risque d'en oublier une.</a:t>
             </a:r>
             <a:endParaRPr lang="en-US" sz="1800" dirty="0"/>
           </a:p>
@@ -27313,7 +27296,7 @@
               <a:buNone/>
             </a:pPr>
             <a:r>
-              <a:rPr lang="en-US" sz="1600" dirty="0">
+              <a:rPr lang="en-US" sz="1500" dirty="0">
                 <a:solidFill>
                   <a:srgbClr val="FFFFFF"/>
                 </a:solidFill>
@@ -27321,7 +27304,7 @@
                 <a:ea typeface="Calibri" pitchFamily="34" charset="-122"/>
                 <a:cs typeface="Calibri" pitchFamily="34" charset="-120"/>
               </a:rPr>
-              <a:t>Le copier-coller est un « code smell » : une odeur de code.</a:t>
+              <a:t>Les développeurs appellent cela un « code smell » : une odeur de code, signe que la conception peut être améliorée.</a:t>
             </a:r>
             <a:endParaRPr lang="en-US" sz="1800" dirty="0"/>
           </a:p>

</xml_diff>